<commit_message>
docs: registra os três defeitos que só o uso revelou
Os cinco defeitos documentados até aqui apareceram na bancada de medição. Estes
três apareceram de outro jeito: alguém usou o assistente no ar e disse que ele
não achava nada. O registro de perguntas mostrou quais foram feitas e o que
cada uma devolveu, e foi ele que transformou a reclamação em diagnóstico.

O relatório ganha a seção 4.3 com os três, a avaliação ganha a descrição de
cada um e os números da bateria ampliada, e a apresentação ganha o cartão da
pergunta curta recusada. Cobertura e recusa correta passam a 100% nas 45
perguntas, com a ressalva de sempre sobre a variação entre execuções.

As contagens de teste no README acompanham: 1870 unitários, 73 de integração e
80 de ponta a ponta.
</commit_message>
<xml_diff>
--- a/PermaneIA-Apresentacao.pptx
+++ b/PermaneIA-Apresentacao.pptx
@@ -10961,7 +10961,7 @@
                 <a:ea typeface="Verdana" pitchFamily="34" charset="-122"/>
                 <a:cs typeface="Verdana" pitchFamily="34" charset="-120"/>
               </a:rPr>
-              <a:t>Mais dois, e os piores: os que pareciam funcionar</a:t>
+              <a:t>Mais três, e os piores: os que pareciam funcionar</a:t>
             </a:r>
             <a:endParaRPr lang="en-US" sz="2800" dirty="0"/>
           </a:p>
@@ -10975,12 +10975,12 @@
         </p:nvSpPr>
         <p:spPr>
           <a:xfrm>
-            <a:off x="640080" y="2011680"/>
-            <a:ext cx="10881360" cy="1645920"/>
+            <a:off x="640080" y="1828800"/>
+            <a:ext cx="10881360" cy="1371600"/>
           </a:xfrm>
           <a:prstGeom prst="roundRect">
             <a:avLst>
-              <a:gd name="adj" fmla="val 4444"/>
+              <a:gd name="adj" fmla="val 5333"/>
             </a:avLst>
           </a:prstGeom>
           <a:solidFill>
@@ -11002,7 +11002,7 @@
         </p:nvSpPr>
         <p:spPr>
           <a:xfrm>
-            <a:off x="914400" y="2194560"/>
+            <a:off x="914400" y="1965960"/>
             <a:ext cx="4206240" cy="320040"/>
           </a:xfrm>
           <a:prstGeom prst="rect">
@@ -11019,7 +11019,7 @@
               <a:buNone/>
             </a:pPr>
             <a:r>
-              <a:rPr lang="en-US" sz="1500" b="1" dirty="0">
+              <a:rPr lang="en-US" sz="1400" b="1" dirty="0">
                 <a:solidFill>
                   <a:srgbClr val="FFFFFF"/>
                 </a:solidFill>
@@ -11029,7 +11029,7 @@
               </a:rPr>
               <a:t>Enumeração com um item só</a:t>
             </a:r>
-            <a:endParaRPr lang="en-US" sz="1500" dirty="0"/>
+            <a:endParaRPr lang="en-US" sz="1400" dirty="0"/>
           </a:p>
         </p:txBody>
       </p:sp>
@@ -11041,7 +11041,7 @@
         </p:nvSpPr>
         <p:spPr>
           <a:xfrm>
-            <a:off x="914400" y="2633472"/>
+            <a:off x="914400" y="2359152"/>
             <a:ext cx="4206240" cy="320040"/>
           </a:xfrm>
           <a:prstGeom prst="rect">
@@ -11058,7 +11058,7 @@
               <a:buNone/>
             </a:pPr>
             <a:r>
-              <a:rPr lang="en-US" sz="1250" b="1" dirty="0">
+              <a:rPr lang="en-US" sz="1200" b="1" dirty="0">
                 <a:solidFill>
                   <a:srgbClr val="E2703A"/>
                 </a:solidFill>
@@ -11068,7 +11068,7 @@
               </a:rPr>
               <a:t>Cobertura 78% → 91%</a:t>
             </a:r>
-            <a:endParaRPr lang="en-US" sz="1250" dirty="0"/>
+            <a:endParaRPr lang="en-US" sz="1200" dirty="0"/>
           </a:p>
         </p:txBody>
       </p:sp>
@@ -11080,8 +11080,8 @@
         </p:nvSpPr>
         <p:spPr>
           <a:xfrm>
-            <a:off x="5303520" y="2212848"/>
-            <a:ext cx="6035040" cy="1234440"/>
+            <a:off x="5303520" y="1993392"/>
+            <a:ext cx="6035040" cy="1005840"/>
           </a:xfrm>
           <a:prstGeom prst="rect">
             <a:avLst/>
@@ -11100,7 +11100,7 @@
               <a:buNone/>
             </a:pPr>
             <a:r>
-              <a:rPr lang="en-US" sz="1200" dirty="0">
+              <a:rPr lang="en-US" sz="1150" dirty="0">
                 <a:solidFill>
                   <a:srgbClr val="9FADBE"/>
                 </a:solidFill>
@@ -11110,7 +11110,7 @@
               </a:rPr>
               <a:t>"Qual é o conteúdo das aulas?" devolvia a primeira aula do semestre, citada e correta. Similaridade alta, fonte apontada, metade da resposta faltando, e nada sinalizando isso.</a:t>
             </a:r>
-            <a:endParaRPr lang="en-US" sz="1200" dirty="0"/>
+            <a:endParaRPr lang="en-US" sz="1150" dirty="0"/>
           </a:p>
         </p:txBody>
       </p:sp>
@@ -11122,12 +11122,12 @@
         </p:nvSpPr>
         <p:spPr>
           <a:xfrm>
-            <a:off x="640080" y="3840480"/>
-            <a:ext cx="10881360" cy="1645920"/>
+            <a:off x="640080" y="3310128"/>
+            <a:ext cx="10881360" cy="1371600"/>
           </a:xfrm>
           <a:prstGeom prst="roundRect">
             <a:avLst>
-              <a:gd name="adj" fmla="val 4444"/>
+              <a:gd name="adj" fmla="val 5333"/>
             </a:avLst>
           </a:prstGeom>
           <a:solidFill>
@@ -11149,7 +11149,7 @@
         </p:nvSpPr>
         <p:spPr>
           <a:xfrm>
-            <a:off x="914400" y="4023360"/>
+            <a:off x="914400" y="3447288"/>
             <a:ext cx="4206240" cy="320040"/>
           </a:xfrm>
           <a:prstGeom prst="rect">
@@ -11166,7 +11166,7 @@
               <a:buNone/>
             </a:pPr>
             <a:r>
-              <a:rPr lang="en-US" sz="1500" b="1" dirty="0">
+              <a:rPr lang="en-US" sz="1400" b="1" dirty="0">
                 <a:solidFill>
                   <a:srgbClr val="FFFFFF"/>
                 </a:solidFill>
@@ -11176,7 +11176,7 @@
               </a:rPr>
               <a:t>A régua medindo errado</a:t>
             </a:r>
-            <a:endParaRPr lang="en-US" sz="1500" dirty="0"/>
+            <a:endParaRPr lang="en-US" sz="1400" dirty="0"/>
           </a:p>
         </p:txBody>
       </p:sp>
@@ -11188,7 +11188,7 @@
         </p:nvSpPr>
         <p:spPr>
           <a:xfrm>
-            <a:off x="914400" y="4462272"/>
+            <a:off x="914400" y="3840480"/>
             <a:ext cx="4206240" cy="320040"/>
           </a:xfrm>
           <a:prstGeom prst="rect">
@@ -11205,7 +11205,7 @@
               <a:buNone/>
             </a:pPr>
             <a:r>
-              <a:rPr lang="en-US" sz="1250" b="1" dirty="0">
+              <a:rPr lang="en-US" sz="1200" b="1" dirty="0">
                 <a:solidFill>
                   <a:srgbClr val="E2703A"/>
                 </a:solidFill>
@@ -11215,7 +11215,7 @@
               </a:rPr>
               <a:t>Recusa 0/8 → 6/8</a:t>
             </a:r>
-            <a:endParaRPr lang="en-US" sz="1250" dirty="0"/>
+            <a:endParaRPr lang="en-US" sz="1200" dirty="0"/>
           </a:p>
         </p:txBody>
       </p:sp>
@@ -11227,8 +11227,8 @@
         </p:nvSpPr>
         <p:spPr>
           <a:xfrm>
-            <a:off x="5303520" y="4041648"/>
-            <a:ext cx="6035040" cy="1234440"/>
+            <a:off x="5303520" y="3474720"/>
+            <a:ext cx="6035040" cy="1005840"/>
           </a:xfrm>
           <a:prstGeom prst="rect">
             <a:avLst/>
@@ -11247,7 +11247,7 @@
               <a:buNone/>
             </a:pPr>
             <a:r>
-              <a:rPr lang="en-US" sz="1200" dirty="0">
+              <a:rPr lang="en-US" sz="1150" dirty="0">
                 <a:solidFill>
                   <a:srgbClr val="9FADBE"/>
                 </a:solidFill>
@@ -11257,19 +11257,166 @@
               </a:rPr>
               <a:t>A bateria de avaliação aplicava o limiar do modo local (0,15) também ao modo generativo, cujo limiar é 0,65. A métrica media o que a ferramenta fazia, não o que o sistema fazia.</a:t>
             </a:r>
+            <a:endParaRPr lang="en-US" sz="1150" dirty="0"/>
+          </a:p>
+        </p:txBody>
+      </p:sp>
+      <p:sp>
+        <p:nvSpPr>
+          <p:cNvPr id="12" name="Shape 10"/>
+          <p:cNvSpPr/>
+          <p:nvPr/>
+        </p:nvSpPr>
+        <p:spPr>
+          <a:xfrm>
+            <a:off x="640080" y="4791456"/>
+            <a:ext cx="10881360" cy="1371600"/>
+          </a:xfrm>
+          <a:prstGeom prst="roundRect">
+            <a:avLst>
+              <a:gd name="adj" fmla="val 5333"/>
+            </a:avLst>
+          </a:prstGeom>
+          <a:solidFill>
+            <a:srgbClr val="141B26"/>
+          </a:solidFill>
+          <a:ln w="12700">
+            <a:solidFill>
+              <a:srgbClr val="2B3849"/>
+            </a:solidFill>
+            <a:prstDash val="solid"/>
+          </a:ln>
+        </p:spPr>
+      </p:sp>
+      <p:sp>
+        <p:nvSpPr>
+          <p:cNvPr id="13" name="Text 11"/>
+          <p:cNvSpPr/>
+          <p:nvPr/>
+        </p:nvSpPr>
+        <p:spPr>
+          <a:xfrm>
+            <a:off x="914400" y="4928616"/>
+            <a:ext cx="4206240" cy="320040"/>
+          </a:xfrm>
+          <a:prstGeom prst="rect">
+            <a:avLst/>
+          </a:prstGeom>
+          <a:noFill/>
+          <a:ln/>
+        </p:spPr>
+        <p:txBody>
+          <a:bodyPr wrap="square" rtlCol="0" anchor="ctr"/>
+          <a:lstStyle/>
+          <a:p>
+            <a:pPr indent="0" marL="0">
+              <a:buNone/>
+            </a:pPr>
+            <a:r>
+              <a:rPr lang="en-US" sz="1400" b="1" dirty="0">
+                <a:solidFill>
+                  <a:srgbClr val="FFFFFF"/>
+                </a:solidFill>
+                <a:latin typeface="Verdana" pitchFamily="34" charset="0"/>
+                <a:ea typeface="Verdana" pitchFamily="34" charset="-122"/>
+                <a:cs typeface="Verdana" pitchFamily="34" charset="-120"/>
+              </a:rPr>
+              <a:t>Pergunta curta, recusa errada</a:t>
+            </a:r>
+            <a:endParaRPr lang="en-US" sz="1400" dirty="0"/>
+          </a:p>
+        </p:txBody>
+      </p:sp>
+      <p:sp>
+        <p:nvSpPr>
+          <p:cNvPr id="14" name="Text 12"/>
+          <p:cNvSpPr/>
+          <p:nvPr/>
+        </p:nvSpPr>
+        <p:spPr>
+          <a:xfrm>
+            <a:off x="914400" y="5321808"/>
+            <a:ext cx="4206240" cy="320040"/>
+          </a:xfrm>
+          <a:prstGeom prst="rect">
+            <a:avLst/>
+          </a:prstGeom>
+          <a:noFill/>
+          <a:ln/>
+        </p:spPr>
+        <p:txBody>
+          <a:bodyPr wrap="square" rtlCol="0" anchor="ctr"/>
+          <a:lstStyle/>
+          <a:p>
+            <a:pPr indent="0" marL="0">
+              <a:buNone/>
+            </a:pPr>
+            <a:r>
+              <a:rPr lang="en-US" sz="1200" b="1" dirty="0">
+                <a:solidFill>
+                  <a:srgbClr val="E2703A"/>
+                </a:solidFill>
+                <a:latin typeface="Verdana" pitchFamily="34" charset="0"/>
+                <a:ea typeface="Verdana" pitchFamily="34" charset="-122"/>
+                <a:cs typeface="Verdana" pitchFamily="34" charset="-120"/>
+              </a:rPr>
+              <a:t>Cobertura 89% → 100%</a:t>
+            </a:r>
             <a:endParaRPr lang="en-US" sz="1200" dirty="0"/>
           </a:p>
         </p:txBody>
       </p:sp>
       <p:sp>
         <p:nvSpPr>
-          <p:cNvPr id="12" name="Text 10"/>
-          <p:cNvSpPr/>
-          <p:nvPr/>
-        </p:nvSpPr>
-        <p:spPr>
-          <a:xfrm>
-            <a:off x="640080" y="5943600"/>
+          <p:cNvPr id="15" name="Text 13"/>
+          <p:cNvSpPr/>
+          <p:nvPr/>
+        </p:nvSpPr>
+        <p:spPr>
+          <a:xfrm>
+            <a:off x="5303520" y="4956048"/>
+            <a:ext cx="6035040" cy="1005840"/>
+          </a:xfrm>
+          <a:prstGeom prst="rect">
+            <a:avLst/>
+          </a:prstGeom>
+          <a:noFill/>
+          <a:ln/>
+        </p:spPr>
+        <p:txBody>
+          <a:bodyPr wrap="square" rtlCol="0" anchor="ctr"/>
+          <a:lstStyle/>
+          <a:p>
+            <a:pPr indent="0" marL="0">
+              <a:lnSpc>
+                <a:spcPct val="115000"/>
+              </a:lnSpc>
+              <a:buNone/>
+            </a:pPr>
+            <a:r>
+              <a:rPr lang="en-US" sz="1150" dirty="0">
+                <a:solidFill>
+                  <a:srgbClr val="9FADBE"/>
+                </a:solidFill>
+                <a:latin typeface="Verdana" pitchFamily="34" charset="0"/>
+                <a:ea typeface="Verdana" pitchFamily="34" charset="-122"/>
+                <a:cs typeface="Verdana" pitchFamily="34" charset="-120"/>
+              </a:rPr>
+              <a:t>"Quando é a Prova P1?" respondia; "quando vai ser a prova" recusava, com a mesma similaridade. O registro de consultas mostrou o par. A busca ganhou um segundo braço, por casamento de termos.</a:t>
+            </a:r>
+            <a:endParaRPr lang="en-US" sz="1150" dirty="0"/>
+          </a:p>
+        </p:txBody>
+      </p:sp>
+      <p:sp>
+        <p:nvSpPr>
+          <p:cNvPr id="16" name="Text 14"/>
+          <p:cNvSpPr/>
+          <p:nvPr/>
+        </p:nvSpPr>
+        <p:spPr>
+          <a:xfrm>
+            <a:off x="640080" y="6309360"/>
             <a:ext cx="10972800" cy="320040"/>
           </a:xfrm>
           <a:prstGeom prst="rect">
@@ -11286,7 +11433,7 @@
               <a:buNone/>
             </a:pPr>
             <a:r>
-              <a:rPr lang="en-US" sz="1300" b="1" dirty="0">
+              <a:rPr lang="en-US" sz="1200" b="1" dirty="0">
                 <a:solidFill>
                   <a:srgbClr val="E6EAEF"/>
                 </a:solidFill>
@@ -11294,15 +11441,15 @@
                 <a:ea typeface="Verdana" pitchFamily="34" charset="-122"/>
                 <a:cs typeface="Verdana" pitchFamily="34" charset="-120"/>
               </a:rPr>
-              <a:t>Uma métrica que ninguém audita mede o que a ferramenta faz, e não o que o sistema faz.</a:t>
-            </a:r>
-            <a:endParaRPr lang="en-US" sz="1300" dirty="0"/>
-          </a:p>
-        </p:txBody>
-      </p:sp>
-      <p:sp>
-        <p:nvSpPr>
-          <p:cNvPr id="13" name="Text 11"/>
+              <a:t>Os dois primeiros a medição revelou. O terceiro só o uso revelou, e quem o encontrou foi o registro de perguntas.</a:t>
+            </a:r>
+            <a:endParaRPr lang="en-US" sz="1200" dirty="0"/>
+          </a:p>
+        </p:txBody>
+      </p:sp>
+      <p:sp>
+        <p:nvSpPr>
+          <p:cNvPr id="17" name="Text 15"/>
           <p:cNvSpPr/>
           <p:nvPr/>
         </p:nvSpPr>
@@ -11341,7 +11488,7 @@
       </p:sp>
       <p:sp>
         <p:nvSpPr>
-          <p:cNvPr id="14" name="Text 12"/>
+          <p:cNvPr id="18" name="Text 16"/>
           <p:cNvSpPr/>
           <p:nvPr/>
         </p:nvSpPr>
@@ -11548,7 +11695,7 @@
                 <a:ea typeface="Verdana" pitchFamily="34" charset="-122"/>
                 <a:cs typeface="Verdana" pitchFamily="34" charset="-120"/>
               </a:rPr>
-              <a:t>91,3%</a:t>
+              <a:t>100%</a:t>
             </a:r>
             <a:endParaRPr lang="en-US" sz="3400" dirty="0"/>
           </a:p>
@@ -11587,7 +11734,7 @@
                 <a:ea typeface="Verdana" pitchFamily="34" charset="-122"/>
                 <a:cs typeface="Verdana" pitchFamily="34" charset="-120"/>
               </a:rPr>
-              <a:t>das perguntas respondíveis foram respondidas</a:t>
+              <a:t>das 37 perguntas respondíveis foram respondidas</a:t>
             </a:r>
             <a:endParaRPr lang="en-US" sz="1100" dirty="0"/>
           </a:p>
@@ -11653,7 +11800,7 @@
                 <a:ea typeface="Verdana" pitchFamily="34" charset="-122"/>
                 <a:cs typeface="Verdana" pitchFamily="34" charset="-120"/>
               </a:rPr>
-              <a:t>75,0%</a:t>
+              <a:t>100%</a:t>
             </a:r>
             <a:endParaRPr lang="en-US" sz="3400" dirty="0"/>
           </a:p>
@@ -11692,7 +11839,7 @@
                 <a:ea typeface="Verdana" pitchFamily="34" charset="-122"/>
                 <a:cs typeface="Verdana" pitchFamily="34" charset="-120"/>
               </a:rPr>
-              <a:t>das perguntas fora do material foram recusadas</a:t>
+              <a:t>das 8 perguntas fora do material foram recusadas</a:t>
             </a:r>
             <a:endParaRPr lang="en-US" sz="1100" dirty="0"/>
           </a:p>

</xml_diff>